<commit_message>
Add SingHacks and Ripple marks to the banner and deck
Ripple's lockup is carved out of the challenge statement PDF and keyed off its
black ground, so it keeps its own blue. The SingHacks wordmark is taken from the
organisation avatar and reduced to a single-colour lockup — the alpha bounding
box comes from the mask, not the fill, or the crop collapses.

Both appear as a 'BUILT FOR' strip: bottom right of the repository banner, and
on the title and closing slides of the deck.
</commit_message>
<xml_diff>
--- a/deck/KIRIM-pitch-deck.pptx
+++ b/deck/KIRIM-pitch-deck.pptx
@@ -3320,7 +3320,7 @@
         <p:spPr>
           <a:xfrm>
             <a:off x="777240" y="5806440"/>
-            <a:ext cx="10637215" cy="457200"/>
+            <a:ext cx="5486400" cy="457200"/>
           </a:xfrm>
           <a:prstGeom prst="rect">
             <a:avLst/>
@@ -3349,6 +3349,140 @@
                 <a:latin typeface="Consolas"/>
               </a:rPr>
               <a:t>Less blind trust. More visible proof.</a:t>
+            </a:r>
+          </a:p>
+        </p:txBody>
+      </p:sp>
+      <p:pic>
+        <p:nvPicPr>
+          <p:cNvPr id="7" name="Picture 6" descr="ripple.png"/>
+          <p:cNvPicPr>
+            <a:picLocks noChangeAspect="1"/>
+          </p:cNvPicPr>
+          <p:nvPr/>
+        </p:nvPicPr>
+        <p:blipFill>
+          <a:blip r:embed="rId2"/>
+          <a:stretch>
+            <a:fillRect/>
+          </a:stretch>
+        </p:blipFill>
+        <p:spPr>
+          <a:xfrm>
+            <a:off x="10345676" y="5687568"/>
+            <a:ext cx="1068779" cy="274320"/>
+          </a:xfrm>
+          <a:prstGeom prst="rect">
+            <a:avLst/>
+          </a:prstGeom>
+        </p:spPr>
+      </p:pic>
+      <p:sp>
+        <p:nvSpPr>
+          <p:cNvPr id="8" name="Rectangle 7"/>
+          <p:cNvSpPr/>
+          <p:nvPr/>
+        </p:nvSpPr>
+        <p:spPr>
+          <a:xfrm>
+            <a:off x="10089644" y="5669280"/>
+            <a:ext cx="9525" cy="310896"/>
+          </a:xfrm>
+          <a:prstGeom prst="rect">
+            <a:avLst/>
+          </a:prstGeom>
+          <a:solidFill>
+            <a:srgbClr val="262119"/>
+          </a:solidFill>
+          <a:ln>
+            <a:noFill/>
+          </a:ln>
+          <a:effectLst/>
+        </p:spPr>
+        <p:style>
+          <a:lnRef idx="1">
+            <a:schemeClr val="accent1"/>
+          </a:lnRef>
+          <a:fillRef idx="3">
+            <a:schemeClr val="accent1"/>
+          </a:fillRef>
+          <a:effectRef idx="2">
+            <a:schemeClr val="accent1"/>
+          </a:effectRef>
+          <a:fontRef idx="minor">
+            <a:schemeClr val="lt1"/>
+          </a:fontRef>
+        </p:style>
+        <p:txBody>
+          <a:bodyPr rtlCol="0" anchor="ctr"/>
+          <a:lstStyle/>
+          <a:p>
+            <a:pPr algn="ctr"/>
+          </a:p>
+        </p:txBody>
+      </p:sp>
+      <p:pic>
+        <p:nvPicPr>
+          <p:cNvPr id="9" name="Picture 8" descr="singhacks.png"/>
+          <p:cNvPicPr>
+            <a:picLocks noChangeAspect="1"/>
+          </p:cNvPicPr>
+          <p:nvPr/>
+        </p:nvPicPr>
+        <p:blipFill>
+          <a:blip r:embed="rId3"/>
+          <a:stretch>
+            <a:fillRect/>
+          </a:stretch>
+        </p:blipFill>
+        <p:spPr>
+          <a:xfrm>
+            <a:off x="9172631" y="5669280"/>
+            <a:ext cx="660981" cy="310896"/>
+          </a:xfrm>
+          <a:prstGeom prst="rect">
+            <a:avLst/>
+          </a:prstGeom>
+        </p:spPr>
+      </p:pic>
+      <p:sp>
+        <p:nvSpPr>
+          <p:cNvPr id="10" name="TextBox 9"/>
+          <p:cNvSpPr txBox="1"/>
+          <p:nvPr/>
+        </p:nvSpPr>
+        <p:spPr>
+          <a:xfrm>
+            <a:off x="7938191" y="5715000"/>
+            <a:ext cx="1051560" cy="274320"/>
+          </a:xfrm>
+          <a:prstGeom prst="rect">
+            <a:avLst/>
+          </a:prstGeom>
+          <a:noFill/>
+        </p:spPr>
+        <p:txBody>
+          <a:bodyPr wrap="square" lIns="0" rIns="0" tIns="0" bIns="0" anchor="t">
+            <a:spAutoFit/>
+          </a:bodyPr>
+          <a:lstStyle/>
+          <a:p>
+            <a:pPr algn="r">
+              <a:lnSpc>
+                <a:spcPct val="135000"/>
+              </a:lnSpc>
+              <a:spcAft>
+                <a:spcPts val="0"/>
+              </a:spcAft>
+            </a:pPr>
+            <a:r>
+              <a:rPr sz="900" b="0" i="0" spc="16">
+                <a:solidFill>
+                  <a:srgbClr val="7D766A"/>
+                </a:solidFill>
+                <a:latin typeface="Consolas"/>
+              </a:rPr>
+              <a:t>BUILT FOR</a:t>
             </a:r>
           </a:p>
         </p:txBody>
@@ -8363,7 +8497,7 @@
         <p:spPr>
           <a:xfrm>
             <a:off x="777240" y="5349240"/>
-            <a:ext cx="10607040" cy="548640"/>
+            <a:ext cx="6400800" cy="548640"/>
           </a:xfrm>
           <a:prstGeom prst="rect">
             <a:avLst/>
@@ -8392,6 +8526,140 @@
                 <a:latin typeface="Consolas"/>
               </a:rPr>
               <a:t>KIRIM  ·  LESS BLIND TRUST. MORE VISIBLE PROOF.</a:t>
+            </a:r>
+          </a:p>
+        </p:txBody>
+      </p:sp>
+      <p:pic>
+        <p:nvPicPr>
+          <p:cNvPr id="6" name="Picture 5" descr="ripple.png"/>
+          <p:cNvPicPr>
+            <a:picLocks noChangeAspect="1"/>
+          </p:cNvPicPr>
+          <p:nvPr/>
+        </p:nvPicPr>
+        <p:blipFill>
+          <a:blip r:embed="rId2"/>
+          <a:stretch>
+            <a:fillRect/>
+          </a:stretch>
+        </p:blipFill>
+        <p:spPr>
+          <a:xfrm>
+            <a:off x="10345676" y="5285232"/>
+            <a:ext cx="1068779" cy="274320"/>
+          </a:xfrm>
+          <a:prstGeom prst="rect">
+            <a:avLst/>
+          </a:prstGeom>
+        </p:spPr>
+      </p:pic>
+      <p:sp>
+        <p:nvSpPr>
+          <p:cNvPr id="7" name="Rectangle 6"/>
+          <p:cNvSpPr/>
+          <p:nvPr/>
+        </p:nvSpPr>
+        <p:spPr>
+          <a:xfrm>
+            <a:off x="10089644" y="5266944"/>
+            <a:ext cx="9525" cy="310896"/>
+          </a:xfrm>
+          <a:prstGeom prst="rect">
+            <a:avLst/>
+          </a:prstGeom>
+          <a:solidFill>
+            <a:srgbClr val="262119"/>
+          </a:solidFill>
+          <a:ln>
+            <a:noFill/>
+          </a:ln>
+          <a:effectLst/>
+        </p:spPr>
+        <p:style>
+          <a:lnRef idx="1">
+            <a:schemeClr val="accent1"/>
+          </a:lnRef>
+          <a:fillRef idx="3">
+            <a:schemeClr val="accent1"/>
+          </a:fillRef>
+          <a:effectRef idx="2">
+            <a:schemeClr val="accent1"/>
+          </a:effectRef>
+          <a:fontRef idx="minor">
+            <a:schemeClr val="lt1"/>
+          </a:fontRef>
+        </p:style>
+        <p:txBody>
+          <a:bodyPr rtlCol="0" anchor="ctr"/>
+          <a:lstStyle/>
+          <a:p>
+            <a:pPr algn="ctr"/>
+          </a:p>
+        </p:txBody>
+      </p:sp>
+      <p:pic>
+        <p:nvPicPr>
+          <p:cNvPr id="8" name="Picture 7" descr="singhacks.png"/>
+          <p:cNvPicPr>
+            <a:picLocks noChangeAspect="1"/>
+          </p:cNvPicPr>
+          <p:nvPr/>
+        </p:nvPicPr>
+        <p:blipFill>
+          <a:blip r:embed="rId3"/>
+          <a:stretch>
+            <a:fillRect/>
+          </a:stretch>
+        </p:blipFill>
+        <p:spPr>
+          <a:xfrm>
+            <a:off x="9172631" y="5266944"/>
+            <a:ext cx="660981" cy="310896"/>
+          </a:xfrm>
+          <a:prstGeom prst="rect">
+            <a:avLst/>
+          </a:prstGeom>
+        </p:spPr>
+      </p:pic>
+      <p:sp>
+        <p:nvSpPr>
+          <p:cNvPr id="9" name="TextBox 8"/>
+          <p:cNvSpPr txBox="1"/>
+          <p:nvPr/>
+        </p:nvSpPr>
+        <p:spPr>
+          <a:xfrm>
+            <a:off x="7938191" y="5312664"/>
+            <a:ext cx="1051560" cy="274320"/>
+          </a:xfrm>
+          <a:prstGeom prst="rect">
+            <a:avLst/>
+          </a:prstGeom>
+          <a:noFill/>
+        </p:spPr>
+        <p:txBody>
+          <a:bodyPr wrap="square" lIns="0" rIns="0" tIns="0" bIns="0" anchor="t">
+            <a:spAutoFit/>
+          </a:bodyPr>
+          <a:lstStyle/>
+          <a:p>
+            <a:pPr algn="r">
+              <a:lnSpc>
+                <a:spcPct val="135000"/>
+              </a:lnSpc>
+              <a:spcAft>
+                <a:spcPts val="0"/>
+              </a:spcAft>
+            </a:pPr>
+            <a:r>
+              <a:rPr sz="900" b="0" i="0" spc="16">
+                <a:solidFill>
+                  <a:srgbClr val="7D766A"/>
+                </a:solidFill>
+                <a:latin typeface="Consolas"/>
+              </a:rPr>
+              <a:t>BUILT FOR</a:t>
             </a:r>
           </a:p>
         </p:txBody>

</xml_diff>